<commit_message>
documentacao e deck com a selecao de features, o efeito ano e as duas variantes do modelo do aluno
</commit_message>
<xml_diff>
--- a/reports/slides/RM372204 - Guilherme Cosme - Tech Challenge Fase 03.pptx
+++ b/reports/slides/RM372204 - Guilherme Cosme - Tech Challenge Fase 03.pptx
@@ -8948,7 +8948,7 @@
                 </a:solidFill>
                 <a:latin typeface="Calibri"/>
               </a:rPr>
-              <a:t>Os microdados não trazem variáveis do aluno; o modelo usa contexto de escola e município. A ordenação de risco se manteve no ano seguinte (AUC de validação e de teste próximos).</a:t>
+              <a:t>Os microdados não trazem variáveis do aluno; o modelo usa contexto de escola e município. A variante sem as variáveis medidas no dia da prova, para triagem antecipada, fica em AUC 0,64.</a:t>
             </a:r>
           </a:p>
         </p:txBody>
@@ -9842,7 +9842,7 @@
                 </a:solidFill>
                 <a:latin typeface="Calibri"/>
               </a:rPr>
-              <a:t>914</a:t>
+              <a:t>936</a:t>
             </a:r>
           </a:p>
           <a:p>
@@ -9858,7 +9858,7 @@
                 </a:solidFill>
                 <a:latin typeface="Calibri"/>
               </a:rPr>
-              <a:t>de 5.477 municípios com risco acima de 50% de não atingir a meta de 2026</a:t>
+              <a:t>de 5.477 municípios com risco acima de 50% de não atingir a meta de 2026 (incerteza entre anos incluída)</a:t>
             </a:r>
           </a:p>
         </p:txBody>
@@ -9937,7 +9937,7 @@
                 </a:solidFill>
                 <a:latin typeface="Calibri"/>
               </a:rPr>
-              <a:t>69% dos municípios, salto mediano de 10 p.p.</a:t>
+              <a:t>70% dos municípios, salto mediano de 10 p.p.</a:t>
             </a:r>
           </a:p>
         </p:txBody>
@@ -9981,7 +9981,7 @@
                 </a:solidFill>
                 <a:latin typeface="Calibri"/>
               </a:rPr>
-              <a:t>41% dos municípios, salto mediano de 2 p.p.</a:t>
+              <a:t>42% dos municípios, salto mediano de 2 p.p.</a:t>
             </a:r>
           </a:p>
         </p:txBody>
@@ -10104,7 +10104,7 @@
                 </a:solidFill>
                 <a:latin typeface="Calibri"/>
               </a:rPr>
-              <a:t>SC  </a:t>
+              <a:t>AM  </a:t>
             </a:r>
             <a:r>
               <a:rPr sz="1100" b="0">
@@ -10113,7 +10113,7 @@
                 </a:solidFill>
                 <a:latin typeface="Calibri"/>
               </a:rPr>
-              <a:t>24% dos municípios, salto mediano de 1 p.p.</a:t>
+              <a:t>25% dos municípios, salto mediano de 7 p.p.</a:t>
             </a:r>
           </a:p>
         </p:txBody>
@@ -10127,7 +10127,7 @@
         <p:spPr>
           <a:xfrm>
             <a:off x="8412480" y="5440680"/>
-            <a:ext cx="3154680" cy="822960"/>
+            <a:ext cx="3154680" cy="914400"/>
           </a:xfrm>
           <a:prstGeom prst="rect">
             <a:avLst/>
@@ -10142,13 +10142,13 @@
           <a:p>
             <a:pPr algn="l"/>
             <a:r>
-              <a:rPr sz="1100" b="0">
+              <a:rPr sz="1000" b="0">
                 <a:solidFill>
                   <a:srgbClr val="555555"/>
                 </a:solidFill>
                 <a:latin typeface="Calibri"/>
               </a:rPr>
-              <a:t>Lista completa por município, com os fatores de cada um, em reports/municipios_risco_2026.csv</a:t>
+              <a:t>No RS a meta foi ancorada no nível de 2023, anterior à queda de 2024; o risco alto reflete a distância para a meta, não a condição das redes. Lista completa em reports/municipios_risco_2026.csv.</a:t>
             </a:r>
           </a:p>
         </p:txBody>

</xml_diff>

<commit_message>
ajustes no deck: caixa do risco de 2026 sem sobreposicao, lista de fatores por modelo e decimais com virgula
</commit_message>
<xml_diff>
--- a/reports/slides/RM372204 - Guilherme Cosme - Tech Challenge Fase 03.pptx
+++ b/reports/slides/RM372204 - Guilherme Cosme - Tech Challenge Fase 03.pptx
@@ -3736,8 +3736,8 @@
         </p:blipFill>
         <p:spPr>
           <a:xfrm>
-            <a:off x="457200" y="2558013"/>
-            <a:ext cx="7589520" cy="2747812"/>
+            <a:off x="457200" y="2645318"/>
+            <a:ext cx="7589520" cy="2573202"/>
           </a:xfrm>
           <a:prstGeom prst="rect">
             <a:avLst/>
@@ -3778,7 +3778,7 @@
                 </a:solidFill>
                 <a:latin typeface="Calibri"/>
               </a:rPr>
-              <a:t>Nos dois modelos, em ordem:</a:t>
+              <a:t>Modelo do município, em ordem:</a:t>
             </a:r>
           </a:p>
           <a:p>
@@ -3890,7 +3890,7 @@
                 </a:solidFill>
                 <a:latin typeface="Calibri"/>
               </a:rPr>
-              <a:t>SHAP e permutação concordam: histórico da rede, IDEB, UF e presença na prova vêm antes das variáveis de renda.</a:t>
+              <a:t>No modelo do aluno o histórico da rede também vem primeiro; depois salto para a meta, presença na prova e IDEB. Nos dois, as variáveis de renda ficam atrás das que a gestão da rede acompanha.</a:t>
             </a:r>
           </a:p>
         </p:txBody>
@@ -8794,7 +8794,7 @@
                 </a:solidFill>
                 <a:latin typeface="Calibri"/>
               </a:rPr>
-              <a:t>0.65</a:t>
+              <a:t>0,65</a:t>
             </a:r>
           </a:p>
           <a:p>
@@ -8810,7 +8810,7 @@
                 </a:solidFill>
                 <a:latin typeface="Calibri"/>
               </a:rPr>
-              <a:t>AUC-ROC no teste de 2025 (validação 2024: 0.66)</a:t>
+              <a:t>AUC-ROC no teste de 2025 (validação 2024: 0,66)</a:t>
             </a:r>
           </a:p>
         </p:txBody>
@@ -9365,7 +9365,7 @@
                 </a:solidFill>
                 <a:latin typeface="Calibri"/>
               </a:rPr>
-              <a:t>AUC 0.81 em 2024 e 0.60 em 2025: a regra das metas mudou entre os anos e o classificador não generaliza.</a:t>
+              <a:t>AUC 0,81 em 2024 e 0,60 em 2025: a regra das metas mudou entre os anos e o classificador não generaliza.</a:t>
             </a:r>
           </a:p>
           <a:p>
@@ -9397,7 +9397,7 @@
                 </a:solidFill>
                 <a:latin typeface="Calibri"/>
               </a:rPr>
-              <a:t>AUC do risco 0.77 em 2025; ordem dos municípios preservada (Spearman 0.69).</a:t>
+              <a:t>AUC do risco 0,77 em 2025; ordem dos municípios preservada (Spearman 0,69).</a:t>
             </a:r>
           </a:p>
         </p:txBody>
@@ -9769,7 +9769,7 @@
         <p:spPr>
           <a:xfrm>
             <a:off x="8412480" y="1783080"/>
-            <a:ext cx="3154680" cy="1280160"/>
+            <a:ext cx="3154680" cy="1600200"/>
           </a:xfrm>
           <a:prstGeom prst="roundRect">
             <a:avLst>
@@ -9817,7 +9817,7 @@
         <p:spPr>
           <a:xfrm>
             <a:off x="8641080" y="1965960"/>
-            <a:ext cx="2697480" cy="914399"/>
+            <a:ext cx="2697480" cy="1234440"/>
           </a:xfrm>
           <a:prstGeom prst="rect">
             <a:avLst/>
@@ -9858,7 +9858,7 @@
                 </a:solidFill>
                 <a:latin typeface="Calibri"/>
               </a:rPr>
-              <a:t>de 5.477 municípios com risco acima de 50% de não atingir a meta de 2026 (incerteza entre anos incluída)</a:t>
+              <a:t>de 5.477 municípios com risco acima de 50% de não atingir a meta de 2026, já com a incerteza entre anos</a:t>
             </a:r>
           </a:p>
         </p:txBody>
@@ -9871,8 +9871,8 @@
         </p:nvSpPr>
         <p:spPr>
           <a:xfrm>
-            <a:off x="8412480" y="3246120"/>
-            <a:ext cx="3154680" cy="365760"/>
+            <a:off x="8412480" y="3566160"/>
+            <a:ext cx="3154680" cy="320040"/>
           </a:xfrm>
           <a:prstGeom prst="rect">
             <a:avLst/>
@@ -9906,7 +9906,7 @@
         </p:nvSpPr>
         <p:spPr>
           <a:xfrm>
-            <a:off x="8412480" y="3611880"/>
+            <a:off x="8412480" y="3840480"/>
             <a:ext cx="3154680" cy="274320"/>
           </a:xfrm>
           <a:prstGeom prst="rect">
@@ -9922,22 +9922,13 @@
           <a:p>
             <a:pPr algn="l"/>
             <a:r>
-              <a:rPr sz="1200" b="1">
-                <a:solidFill>
-                  <a:srgbClr val="ED145B"/>
-                </a:solidFill>
-                <a:latin typeface="Calibri"/>
-              </a:rPr>
-              <a:t>RS  </a:t>
-            </a:r>
-            <a:r>
-              <a:rPr sz="1100" b="0">
+              <a:rPr sz="1000" b="0">
                 <a:solidFill>
                   <a:srgbClr val="555555"/>
                 </a:solidFill>
                 <a:latin typeface="Calibri"/>
               </a:rPr>
-              <a:t>70% dos municípios, salto mediano de 10 p.p.</a:t>
+              <a:t>% dos municípios da UF e salto mediano até a meta</a:t>
             </a:r>
           </a:p>
         </p:txBody>
@@ -9950,8 +9941,8 @@
         </p:nvSpPr>
         <p:spPr>
           <a:xfrm>
-            <a:off x="8412480" y="3941064"/>
-            <a:ext cx="3154680" cy="274320"/>
+            <a:off x="8412480" y="4114800"/>
+            <a:ext cx="3154680" cy="256032"/>
           </a:xfrm>
           <a:prstGeom prst="rect">
             <a:avLst/>
@@ -9972,7 +9963,7 @@
                 </a:solidFill>
                 <a:latin typeface="Calibri"/>
               </a:rPr>
-              <a:t>SP  </a:t>
+              <a:t>RS   </a:t>
             </a:r>
             <a:r>
               <a:rPr sz="1100" b="0">
@@ -9981,7 +9972,7 @@
                 </a:solidFill>
                 <a:latin typeface="Calibri"/>
               </a:rPr>
-              <a:t>42% dos municípios, salto mediano de 2 p.p.</a:t>
+              <a:t>70% em risco, salto de 10 p.p.</a:t>
             </a:r>
           </a:p>
         </p:txBody>
@@ -9994,8 +9985,8 @@
         </p:nvSpPr>
         <p:spPr>
           <a:xfrm>
-            <a:off x="8412480" y="4270248"/>
-            <a:ext cx="3154680" cy="274320"/>
+            <a:off x="8412480" y="4389120"/>
+            <a:ext cx="3154680" cy="256032"/>
           </a:xfrm>
           <a:prstGeom prst="rect">
             <a:avLst/>
@@ -10016,7 +10007,7 @@
                 </a:solidFill>
                 <a:latin typeface="Calibri"/>
               </a:rPr>
-              <a:t>RJ  </a:t>
+              <a:t>SP   </a:t>
             </a:r>
             <a:r>
               <a:rPr sz="1100" b="0">
@@ -10025,7 +10016,7 @@
                 </a:solidFill>
                 <a:latin typeface="Calibri"/>
               </a:rPr>
-              <a:t>36% dos municípios, salto mediano de 3 p.p.</a:t>
+              <a:t>42% em risco, salto de 2 p.p.</a:t>
             </a:r>
           </a:p>
         </p:txBody>
@@ -10038,8 +10029,8 @@
         </p:nvSpPr>
         <p:spPr>
           <a:xfrm>
-            <a:off x="8412480" y="4599432"/>
-            <a:ext cx="3154680" cy="274320"/>
+            <a:off x="8412480" y="4663440"/>
+            <a:ext cx="3154680" cy="256032"/>
           </a:xfrm>
           <a:prstGeom prst="rect">
             <a:avLst/>
@@ -10060,7 +10051,7 @@
                 </a:solidFill>
                 <a:latin typeface="Calibri"/>
               </a:rPr>
-              <a:t>RN  </a:t>
+              <a:t>RJ   </a:t>
             </a:r>
             <a:r>
               <a:rPr sz="1100" b="0">
@@ -10069,7 +10060,7 @@
                 </a:solidFill>
                 <a:latin typeface="Calibri"/>
               </a:rPr>
-              <a:t>28% dos municípios, salto mediano de 3 p.p.</a:t>
+              <a:t>36% em risco, salto de 3 p.p.</a:t>
             </a:r>
           </a:p>
         </p:txBody>
@@ -10082,8 +10073,8 @@
         </p:nvSpPr>
         <p:spPr>
           <a:xfrm>
-            <a:off x="8412480" y="4928616"/>
-            <a:ext cx="3154680" cy="274320"/>
+            <a:off x="8412480" y="4937759"/>
+            <a:ext cx="3154680" cy="256032"/>
           </a:xfrm>
           <a:prstGeom prst="rect">
             <a:avLst/>
@@ -10104,7 +10095,7 @@
                 </a:solidFill>
                 <a:latin typeface="Calibri"/>
               </a:rPr>
-              <a:t>AM  </a:t>
+              <a:t>RN   </a:t>
             </a:r>
             <a:r>
               <a:rPr sz="1100" b="0">
@@ -10113,7 +10104,7 @@
                 </a:solidFill>
                 <a:latin typeface="Calibri"/>
               </a:rPr>
-              <a:t>25% dos municípios, salto mediano de 7 p.p.</a:t>
+              <a:t>28% em risco, salto de 3 p.p.</a:t>
             </a:r>
           </a:p>
         </p:txBody>
@@ -10126,8 +10117,8 @@
         </p:nvSpPr>
         <p:spPr>
           <a:xfrm>
-            <a:off x="8412480" y="5440680"/>
-            <a:ext cx="3154680" cy="914400"/>
+            <a:off x="8412480" y="5212079"/>
+            <a:ext cx="3154680" cy="256032"/>
           </a:xfrm>
           <a:prstGeom prst="rect">
             <a:avLst/>
@@ -10142,20 +10133,64 @@
           <a:p>
             <a:pPr algn="l"/>
             <a:r>
+              <a:rPr sz="1200" b="1">
+                <a:solidFill>
+                  <a:srgbClr val="ED145B"/>
+                </a:solidFill>
+                <a:latin typeface="Calibri"/>
+              </a:rPr>
+              <a:t>AM   </a:t>
+            </a:r>
+            <a:r>
+              <a:rPr sz="1100" b="0">
+                <a:solidFill>
+                  <a:srgbClr val="555555"/>
+                </a:solidFill>
+                <a:latin typeface="Calibri"/>
+              </a:rPr>
+              <a:t>25% em risco, salto de 7 p.p.</a:t>
+            </a:r>
+          </a:p>
+        </p:txBody>
+      </p:sp>
+      <p:sp>
+        <p:nvSpPr>
+          <p:cNvPr id="16" name="TextBox 15"/>
+          <p:cNvSpPr txBox="1"/>
+          <p:nvPr/>
+        </p:nvSpPr>
+        <p:spPr>
+          <a:xfrm>
+            <a:off x="8412480" y="5532120"/>
+            <a:ext cx="3154680" cy="822960"/>
+          </a:xfrm>
+          <a:prstGeom prst="rect">
+            <a:avLst/>
+          </a:prstGeom>
+          <a:noFill/>
+        </p:spPr>
+        <p:txBody>
+          <a:bodyPr wrap="square" anchor="t" lIns="0" rIns="0" tIns="0" bIns="0">
+            <a:spAutoFit/>
+          </a:bodyPr>
+          <a:lstStyle/>
+          <a:p>
+            <a:pPr algn="l"/>
+            <a:r>
               <a:rPr sz="1000" b="0">
                 <a:solidFill>
                   <a:srgbClr val="555555"/>
                 </a:solidFill>
                 <a:latin typeface="Calibri"/>
               </a:rPr>
-              <a:t>No RS a meta foi ancorada no nível de 2023, anterior à queda de 2024; o risco alto reflete a distância para a meta, não a condição das redes. Lista completa em reports/municipios_risco_2026.csv.</a:t>
-            </a:r>
-          </a:p>
-        </p:txBody>
-      </p:sp>
-      <p:sp>
-        <p:nvSpPr>
-          <p:cNvPr id="16" name="Rectangle 15"/>
+              <a:t>No RS a meta foi ancorada no nível de 2023, anterior à queda de 2024: o risco alto mede a distância até a meta, não a condição das redes. Lista completa em reports/municipios_risco_2026.csv.</a:t>
+            </a:r>
+          </a:p>
+        </p:txBody>
+      </p:sp>
+      <p:sp>
+        <p:nvSpPr>
+          <p:cNvPr id="17" name="Rectangle 16"/>
           <p:cNvSpPr/>
           <p:nvPr/>
         </p:nvSpPr>
@@ -10199,7 +10234,7 @@
       </p:sp>
       <p:sp>
         <p:nvSpPr>
-          <p:cNvPr id="17" name="TextBox 16"/>
+          <p:cNvPr id="18" name="TextBox 17"/>
           <p:cNvSpPr txBox="1"/>
           <p:nvPr/>
         </p:nvSpPr>
@@ -10234,7 +10269,7 @@
       </p:sp>
       <p:sp>
         <p:nvSpPr>
-          <p:cNvPr id="18" name="TextBox 17"/>
+          <p:cNvPr id="19" name="TextBox 18"/>
           <p:cNvSpPr txBox="1"/>
           <p:nvPr/>
         </p:nvSpPr>
@@ -10459,8 +10494,8 @@
         </p:blipFill>
         <p:spPr>
           <a:xfrm>
-            <a:off x="457200" y="2461019"/>
-            <a:ext cx="7589520" cy="2941800"/>
+            <a:off x="457200" y="2313685"/>
+            <a:ext cx="7589520" cy="3236469"/>
           </a:xfrm>
           <a:prstGeom prst="rect">
             <a:avLst/>

</xml_diff>

<commit_message>
documentacao e deck com os intervalos de confianca e a leitura da calibracao do risco
</commit_message>
<xml_diff>
--- a/reports/slides/RM372204 - Guilherme Cosme - Tech Challenge Fase 03.pptx
+++ b/reports/slides/RM372204 - Guilherme Cosme - Tech Challenge Fase 03.pptx
@@ -8810,7 +8810,7 @@
                 </a:solidFill>
                 <a:latin typeface="Calibri"/>
               </a:rPr>
-              <a:t>AUC-ROC no teste de 2025 (validação 2024: 0,66)</a:t>
+              <a:t>AUC-ROC no teste de 2025, IC 95% 0,638 a 0,656 (validação 2024: 0,66)</a:t>
             </a:r>
           </a:p>
         </p:txBody>
@@ -9397,7 +9397,7 @@
                 </a:solidFill>
                 <a:latin typeface="Calibri"/>
               </a:rPr>
-              <a:t>AUC do risco 0,77 em 2025; ordem dos municípios preservada (Spearman 0,69).</a:t>
+              <a:t>AUC do risco 0,77 em 2025 (IC 95% 0,758 a 0,785); ordem dos municípios preservada (Spearman 0,69).</a:t>
             </a:r>
           </a:p>
         </p:txBody>
@@ -9441,7 +9441,7 @@
                 </a:solidFill>
                 <a:latin typeface="Calibri"/>
               </a:rPr>
-              <a:t>O viés de -7 p.p. em 2025 corresponde ao aumento nacional daquele ano, não previsível a partir de 2024; o reajuste anual faz parte do método.</a:t>
+              <a:t>O viés de -7 p.p. em 2025 corresponde ao aumento nacional daquele ano, não previsível a partir de 2024; é ele que infla o risco no backtest (Brier 0,243, contra 0,189 com o efeito ano) e entra na incerteza de 2026.</a:t>
             </a:r>
           </a:p>
         </p:txBody>

</xml_diff>

<commit_message>
evidencias de robustez consolidadas na documentacao e no deck
</commit_message>
<xml_diff>
--- a/reports/slides/RM372204 - Guilherme Cosme - Tech Challenge Fase 03.pptx
+++ b/reports/slides/RM372204 - Guilherme Cosme - Tech Challenge Fase 03.pptx
@@ -4804,7 +4804,7 @@
                 </a:solidFill>
                 <a:latin typeface="Calibri"/>
               </a:rPr>
-              <a:t>modelo preditivo, não causal; não antecipa choques; reajuste a cada ciclo</a:t>
+              <a:t>modelo preditivo, não causal; não antecipa choques; reajuste a cada ciclo; válido para os 27 estados do treino, não para transferir a outro contexto</a:t>
             </a:r>
           </a:p>
         </p:txBody>
@@ -9275,8 +9275,8 @@
         </p:nvSpPr>
         <p:spPr>
           <a:xfrm>
-            <a:off x="8092440" y="1783080"/>
-            <a:ext cx="3474720" cy="3017520"/>
+            <a:off x="8092440" y="1691640"/>
+            <a:ext cx="3474720" cy="3200400"/>
           </a:xfrm>
           <a:prstGeom prst="roundRect">
             <a:avLst>
@@ -9323,8 +9323,8 @@
         </p:nvSpPr>
         <p:spPr>
           <a:xfrm>
-            <a:off x="8275320" y="1920240"/>
-            <a:ext cx="3108960" cy="2743200"/>
+            <a:off x="8275320" y="1801368"/>
+            <a:ext cx="3108960" cy="3017520"/>
           </a:xfrm>
           <a:prstGeom prst="rect">
             <a:avLst/>
@@ -9398,6 +9398,38 @@
                 <a:latin typeface="Calibri"/>
               </a:rPr>
               <a:t>AUC do risco 0,77 em 2025 (IC 95% 0,758 a 0,785); ordem dos municípios preservada (Spearman 0,69).</a:t>
+            </a:r>
+          </a:p>
+          <a:p>
+            <a:pPr algn="l">
+              <a:spcAft>
+                <a:spcPts val="500"/>
+              </a:spcAft>
+            </a:pPr>
+            <a:r>
+              <a:rPr sz="1300" b="1">
+                <a:solidFill>
+                  <a:srgbClr val="1A1A1A"/>
+                </a:solidFill>
+                <a:latin typeface="Calibri"/>
+              </a:rPr>
+              <a:t>Testes de robustez</a:t>
+            </a:r>
+          </a:p>
+          <a:p>
+            <a:pPr algn="l">
+              <a:spcAft>
+                <a:spcPts val="500"/>
+              </a:spcAft>
+            </a:pPr>
+            <a:r>
+              <a:rPr sz="1100" b="0">
+                <a:solidFill>
+                  <a:srgbClr val="555555"/>
+                </a:solidFill>
+                <a:latin typeface="Calibri"/>
+              </a:rPr>
+              <a:t>Alvo embaralhado vai ao nível da média; ganho sobre a regra "quanto falta para a meta" de +0,029 de AUC, IC que não cruza zero; em estado nunca visto a ordem se mantém e o patamar erra.</a:t>
             </a:r>
           </a:p>
         </p:txBody>

</xml_diff>

<commit_message>
link do video executivo no readme e no deck
</commit_message>
<xml_diff>
--- a/reports/slides/RM372204 - Guilherme Cosme - Tech Challenge Fase 03.pptx
+++ b/reports/slides/RM372204 - Guilherme Cosme - Tech Challenge Fase 03.pptx
@@ -3539,7 +3539,7 @@
                 </a:solidFill>
                 <a:latin typeface="Calibri"/>
               </a:rPr>
-              <a:t>(link do vídeo)</a:t>
+              <a:t>https://www.loom.com/share/447ba58dab7f4fd8ae69ce14f2f96847</a:t>
             </a:r>
           </a:p>
         </p:txBody>
@@ -5296,7 +5296,7 @@
                 </a:solidFill>
                 <a:latin typeface="Calibri"/>
               </a:rPr>
-              <a:t>(link do vídeo)</a:t>
+              <a:t>https://www.loom.com/share/447ba58dab7f4fd8ae69ce14f2f96847</a:t>
             </a:r>
           </a:p>
         </p:txBody>

</xml_diff>

<commit_message>
links clicaveis no deck, arquivo de links do video e do repositorio e pacote zip da entrega
</commit_message>
<xml_diff>
--- a/reports/slides/RM372204 - Guilherme Cosme - Tech Challenge Fase 03.pptx
+++ b/reports/slides/RM372204 - Guilherme Cosme - Tech Challenge Fase 03.pptx
@@ -3489,11 +3489,12 @@
           <a:p>
             <a:pPr algn="l"/>
             <a:r>
-              <a:rPr sz="1200" b="0">
+              <a:rPr sz="1200" b="0" u="sng">
                 <a:solidFill>
                   <a:srgbClr val="555555"/>
                 </a:solidFill>
                 <a:latin typeface="Calibri"/>
+                <a:hlinkClick r:id="rId3"/>
               </a:rPr>
               <a:t>github.com/guillecosme/fiap-ai-scientist-tech-challenge-fase-03</a:t>
             </a:r>
@@ -3533,11 +3534,12 @@
               <a:t>Vídeo executivo (5 min): </a:t>
             </a:r>
             <a:r>
-              <a:rPr sz="1200" b="0">
+              <a:rPr sz="1200" b="0" u="sng">
                 <a:solidFill>
                   <a:srgbClr val="555555"/>
                 </a:solidFill>
                 <a:latin typeface="Calibri"/>
+                <a:hlinkClick r:id="rId4"/>
               </a:rPr>
               <a:t>https://www.loom.com/share/447ba58dab7f4fd8ae69ce14f2f96847</a:t>
             </a:r>
@@ -5246,11 +5248,12 @@
           <a:p>
             <a:pPr algn="l"/>
             <a:r>
-              <a:rPr sz="1200" b="0">
+              <a:rPr sz="1200" b="0" u="sng">
                 <a:solidFill>
                   <a:srgbClr val="555555"/>
                 </a:solidFill>
                 <a:latin typeface="Calibri"/>
+                <a:hlinkClick r:id="rId3"/>
               </a:rPr>
               <a:t>github.com/guillecosme/fiap-ai-scientist-tech-challenge-fase-03</a:t>
             </a:r>
@@ -5290,11 +5293,12 @@
               <a:t>Vídeo executivo (5 min): </a:t>
             </a:r>
             <a:r>
-              <a:rPr sz="1200" b="0">
+              <a:rPr sz="1200" b="0" u="sng">
                 <a:solidFill>
                   <a:srgbClr val="555555"/>
                 </a:solidFill>
                 <a:latin typeface="Calibri"/>
+                <a:hlinkClick r:id="rId4"/>
               </a:rPr>
               <a:t>https://www.loom.com/share/447ba58dab7f4fd8ae69ce14f2f96847</a:t>
             </a:r>
@@ -10778,10 +10782,10 @@
         <a:srgbClr val="F79646"/>
       </a:accent6>
       <a:hlink>
-        <a:srgbClr val="0000FF"/>
+        <a:srgbClr val="555555"/>
       </a:hlink>
       <a:folHlink>
-        <a:srgbClr val="800080"/>
+        <a:srgbClr val="555555"/>
       </a:folHlink>
     </a:clrScheme>
     <a:fontScheme name="Office">

</xml_diff>